<commit_message>
Update Phase 2 documentation and replace guidance images
</commit_message>
<xml_diff>
--- a/docs/src/src_img/guidanceimg/redesign_guidanceImage.pptx
+++ b/docs/src/src_img/guidanceimg/redesign_guidanceImage.pptx
@@ -109,7 +109,239 @@
       </a:defRPr>
     </a:lvl9pPr>
   </p:defaultTextStyle>
+  <p:extLst>
+    <p:ext uri="{EFAFB233-063F-42B5-8137-9DF3F51BA10A}">
+      <p15:sldGuideLst xmlns:p15="http://schemas.microsoft.com/office/powerpoint/2012/main"/>
+    </p:ext>
+  </p:extLst>
 </p:presentation>
+</file>
+
+<file path=ppt/revisionInfo.xml><?xml version="1.0" encoding="utf-8"?>
+<p1510:revInfo xmlns:a="http://schemas.openxmlformats.org/drawingml/2006/main" xmlns:r="http://schemas.openxmlformats.org/officeDocument/2006/relationships" xmlns:p1510="http://schemas.microsoft.com/office/powerpoint/2015/10/main">
+  <p1510:revLst>
+    <p1510:client id="{E67CABE7-1692-4F6F-AAE1-A091EB6F268D}" v="7" dt="2026-03-18T09:57:04.662"/>
+  </p1510:revLst>
+</p1510:revInfo>
+</file>
+
+<file path=ppt/changesInfos/changesInfo1.xml><?xml version="1.0" encoding="utf-8"?>
+<pc:chgInfo xmlns:a="http://schemas.openxmlformats.org/drawingml/2006/main" xmlns:r="http://schemas.openxmlformats.org/officeDocument/2006/relationships" xmlns:ac="http://schemas.microsoft.com/office/drawing/2013/main/command" xmlns:pc="http://schemas.microsoft.com/office/powerpoint/2013/main/command">
+  <pc:docChgLst>
+    <pc:chgData name="Stuart Fraser" userId="3f3d4742-f700-4c44-8ff3-de94e21c092c" providerId="ADAL" clId="{4782FBF3-262C-4F12-9567-4FCBC2EBDED3}"/>
+    <pc:docChg chg="modSld">
+      <pc:chgData name="Stuart Fraser" userId="3f3d4742-f700-4c44-8ff3-de94e21c092c" providerId="ADAL" clId="{4782FBF3-262C-4F12-9567-4FCBC2EBDED3}" dt="2026-03-18T09:57:04.662" v="39"/>
+      <pc:docMkLst>
+        <pc:docMk/>
+      </pc:docMkLst>
+      <pc:sldChg chg="addSp delSp modSp mod">
+        <pc:chgData name="Stuart Fraser" userId="3f3d4742-f700-4c44-8ff3-de94e21c092c" providerId="ADAL" clId="{4782FBF3-262C-4F12-9567-4FCBC2EBDED3}" dt="2026-03-18T09:57:04.662" v="39"/>
+        <pc:sldMkLst>
+          <pc:docMk/>
+          <pc:sldMk cId="2537370530" sldId="258"/>
+        </pc:sldMkLst>
+        <pc:spChg chg="add mod">
+          <ac:chgData name="Stuart Fraser" userId="3f3d4742-f700-4c44-8ff3-de94e21c092c" providerId="ADAL" clId="{4782FBF3-262C-4F12-9567-4FCBC2EBDED3}" dt="2026-03-18T09:57:02.213" v="37" actId="164"/>
+          <ac:spMkLst>
+            <pc:docMk/>
+            <pc:sldMk cId="2537370530" sldId="258"/>
+            <ac:spMk id="3" creationId="{03D0E77F-3659-73AE-F720-BB04B4058136}"/>
+          </ac:spMkLst>
+        </pc:spChg>
+        <pc:spChg chg="mod topLvl">
+          <ac:chgData name="Stuart Fraser" userId="3f3d4742-f700-4c44-8ff3-de94e21c092c" providerId="ADAL" clId="{4782FBF3-262C-4F12-9567-4FCBC2EBDED3}" dt="2026-03-18T09:57:02.213" v="37" actId="164"/>
+          <ac:spMkLst>
+            <pc:docMk/>
+            <pc:sldMk cId="2537370530" sldId="258"/>
+            <ac:spMk id="4" creationId="{8F3203AB-EB93-5BC8-49ED-63F945DE76EB}"/>
+          </ac:spMkLst>
+        </pc:spChg>
+        <pc:spChg chg="mod topLvl">
+          <ac:chgData name="Stuart Fraser" userId="3f3d4742-f700-4c44-8ff3-de94e21c092c" providerId="ADAL" clId="{4782FBF3-262C-4F12-9567-4FCBC2EBDED3}" dt="2026-03-18T09:57:02.213" v="37" actId="164"/>
+          <ac:spMkLst>
+            <pc:docMk/>
+            <pc:sldMk cId="2537370530" sldId="258"/>
+            <ac:spMk id="5" creationId="{3CD6665F-8574-1E22-64D8-9DBF806790D2}"/>
+          </ac:spMkLst>
+        </pc:spChg>
+        <pc:spChg chg="mod topLvl">
+          <ac:chgData name="Stuart Fraser" userId="3f3d4742-f700-4c44-8ff3-de94e21c092c" providerId="ADAL" clId="{4782FBF3-262C-4F12-9567-4FCBC2EBDED3}" dt="2026-03-18T09:57:02.213" v="37" actId="164"/>
+          <ac:spMkLst>
+            <pc:docMk/>
+            <pc:sldMk cId="2537370530" sldId="258"/>
+            <ac:spMk id="6" creationId="{1C2A4EF5-BF04-7F3F-D537-8FB9B0CB3A2C}"/>
+          </ac:spMkLst>
+        </pc:spChg>
+        <pc:spChg chg="add mod">
+          <ac:chgData name="Stuart Fraser" userId="3f3d4742-f700-4c44-8ff3-de94e21c092c" providerId="ADAL" clId="{4782FBF3-262C-4F12-9567-4FCBC2EBDED3}" dt="2026-03-18T09:57:02.213" v="37" actId="164"/>
+          <ac:spMkLst>
+            <pc:docMk/>
+            <pc:sldMk cId="2537370530" sldId="258"/>
+            <ac:spMk id="7" creationId="{51AA527A-B7A0-8489-F95C-ADF4C6719403}"/>
+          </ac:spMkLst>
+        </pc:spChg>
+        <pc:spChg chg="mod topLvl">
+          <ac:chgData name="Stuart Fraser" userId="3f3d4742-f700-4c44-8ff3-de94e21c092c" providerId="ADAL" clId="{4782FBF3-262C-4F12-9567-4FCBC2EBDED3}" dt="2026-03-18T09:57:02.213" v="37" actId="164"/>
+          <ac:spMkLst>
+            <pc:docMk/>
+            <pc:sldMk cId="2537370530" sldId="258"/>
+            <ac:spMk id="8" creationId="{03A11337-5899-10D5-3013-92CACE913C1F}"/>
+          </ac:spMkLst>
+        </pc:spChg>
+        <pc:spChg chg="mod">
+          <ac:chgData name="Stuart Fraser" userId="3f3d4742-f700-4c44-8ff3-de94e21c092c" providerId="ADAL" clId="{4782FBF3-262C-4F12-9567-4FCBC2EBDED3}" dt="2026-03-18T09:57:04.662" v="39"/>
+          <ac:spMkLst>
+            <pc:docMk/>
+            <pc:sldMk cId="2537370530" sldId="258"/>
+            <ac:spMk id="12" creationId="{6A234F04-4106-A0E5-F700-9A116940B5DD}"/>
+          </ac:spMkLst>
+        </pc:spChg>
+        <pc:spChg chg="mod">
+          <ac:chgData name="Stuart Fraser" userId="3f3d4742-f700-4c44-8ff3-de94e21c092c" providerId="ADAL" clId="{4782FBF3-262C-4F12-9567-4FCBC2EBDED3}" dt="2026-03-18T09:57:04.662" v="39"/>
+          <ac:spMkLst>
+            <pc:docMk/>
+            <pc:sldMk cId="2537370530" sldId="258"/>
+            <ac:spMk id="13" creationId="{D4034233-6B6E-99F0-B09C-A3519D6DECA6}"/>
+          </ac:spMkLst>
+        </pc:spChg>
+        <pc:spChg chg="mod">
+          <ac:chgData name="Stuart Fraser" userId="3f3d4742-f700-4c44-8ff3-de94e21c092c" providerId="ADAL" clId="{4782FBF3-262C-4F12-9567-4FCBC2EBDED3}" dt="2026-03-18T09:57:04.662" v="39"/>
+          <ac:spMkLst>
+            <pc:docMk/>
+            <pc:sldMk cId="2537370530" sldId="258"/>
+            <ac:spMk id="14" creationId="{3C91BF85-3C2C-7047-9895-69051BBE01C3}"/>
+          </ac:spMkLst>
+        </pc:spChg>
+        <pc:spChg chg="mod">
+          <ac:chgData name="Stuart Fraser" userId="3f3d4742-f700-4c44-8ff3-de94e21c092c" providerId="ADAL" clId="{4782FBF3-262C-4F12-9567-4FCBC2EBDED3}" dt="2026-03-18T09:57:04.662" v="39"/>
+          <ac:spMkLst>
+            <pc:docMk/>
+            <pc:sldMk cId="2537370530" sldId="258"/>
+            <ac:spMk id="15" creationId="{5A1F471B-3727-0112-543C-797CC18B8612}"/>
+          </ac:spMkLst>
+        </pc:spChg>
+        <pc:spChg chg="mod">
+          <ac:chgData name="Stuart Fraser" userId="3f3d4742-f700-4c44-8ff3-de94e21c092c" providerId="ADAL" clId="{4782FBF3-262C-4F12-9567-4FCBC2EBDED3}" dt="2026-03-18T09:57:04.662" v="39"/>
+          <ac:spMkLst>
+            <pc:docMk/>
+            <pc:sldMk cId="2537370530" sldId="258"/>
+            <ac:spMk id="16" creationId="{A57220FC-7EE0-D75E-73D2-8753A26F172A}"/>
+          </ac:spMkLst>
+        </pc:spChg>
+        <pc:spChg chg="mod">
+          <ac:chgData name="Stuart Fraser" userId="3f3d4742-f700-4c44-8ff3-de94e21c092c" providerId="ADAL" clId="{4782FBF3-262C-4F12-9567-4FCBC2EBDED3}" dt="2026-03-18T09:57:04.662" v="39"/>
+          <ac:spMkLst>
+            <pc:docMk/>
+            <pc:sldMk cId="2537370530" sldId="258"/>
+            <ac:spMk id="17" creationId="{C29E4B80-E904-CF80-A9E2-8BCC52DF5689}"/>
+          </ac:spMkLst>
+        </pc:spChg>
+        <pc:spChg chg="mod">
+          <ac:chgData name="Stuart Fraser" userId="3f3d4742-f700-4c44-8ff3-de94e21c092c" providerId="ADAL" clId="{4782FBF3-262C-4F12-9567-4FCBC2EBDED3}" dt="2026-03-18T09:57:04.662" v="39"/>
+          <ac:spMkLst>
+            <pc:docMk/>
+            <pc:sldMk cId="2537370530" sldId="258"/>
+            <ac:spMk id="18" creationId="{FD1DCA42-5C8E-D8F1-6DC6-F620EE38349D}"/>
+          </ac:spMkLst>
+        </pc:spChg>
+        <pc:spChg chg="mod topLvl">
+          <ac:chgData name="Stuart Fraser" userId="3f3d4742-f700-4c44-8ff3-de94e21c092c" providerId="ADAL" clId="{4782FBF3-262C-4F12-9567-4FCBC2EBDED3}" dt="2026-03-18T09:57:02.213" v="37" actId="164"/>
+          <ac:spMkLst>
+            <pc:docMk/>
+            <pc:sldMk cId="2537370530" sldId="258"/>
+            <ac:spMk id="23" creationId="{5A845D82-EEEF-39C0-8DB6-BA8187547E41}"/>
+          </ac:spMkLst>
+        </pc:spChg>
+        <pc:grpChg chg="add mod">
+          <ac:chgData name="Stuart Fraser" userId="3f3d4742-f700-4c44-8ff3-de94e21c092c" providerId="ADAL" clId="{4782FBF3-262C-4F12-9567-4FCBC2EBDED3}" dt="2026-03-18T09:57:02.213" v="37" actId="164"/>
+          <ac:grpSpMkLst>
+            <pc:docMk/>
+            <pc:sldMk cId="2537370530" sldId="258"/>
+            <ac:grpSpMk id="9" creationId="{F2224106-0FA1-7AAB-B155-D686EB02A6E1}"/>
+          </ac:grpSpMkLst>
+        </pc:grpChg>
+        <pc:grpChg chg="add mod">
+          <ac:chgData name="Stuart Fraser" userId="3f3d4742-f700-4c44-8ff3-de94e21c092c" providerId="ADAL" clId="{4782FBF3-262C-4F12-9567-4FCBC2EBDED3}" dt="2026-03-18T09:57:04.662" v="39"/>
+          <ac:grpSpMkLst>
+            <pc:docMk/>
+            <pc:sldMk cId="2537370530" sldId="258"/>
+            <ac:grpSpMk id="10" creationId="{4ED4BC07-9DB4-CF99-A9CA-221E6C0C621E}"/>
+          </ac:grpSpMkLst>
+        </pc:grpChg>
+        <pc:grpChg chg="del mod">
+          <ac:chgData name="Stuart Fraser" userId="3f3d4742-f700-4c44-8ff3-de94e21c092c" providerId="ADAL" clId="{4782FBF3-262C-4F12-9567-4FCBC2EBDED3}" dt="2026-03-18T09:56:53.133" v="35" actId="165"/>
+          <ac:grpSpMkLst>
+            <pc:docMk/>
+            <pc:sldMk cId="2537370530" sldId="258"/>
+            <ac:grpSpMk id="24" creationId="{4FB0F79C-3646-B32F-9F26-35175F338988}"/>
+          </ac:grpSpMkLst>
+        </pc:grpChg>
+        <pc:picChg chg="mod topLvl">
+          <ac:chgData name="Stuart Fraser" userId="3f3d4742-f700-4c44-8ff3-de94e21c092c" providerId="ADAL" clId="{4782FBF3-262C-4F12-9567-4FCBC2EBDED3}" dt="2026-03-18T09:57:02.213" v="37" actId="164"/>
+          <ac:picMkLst>
+            <pc:docMk/>
+            <pc:sldMk cId="2537370530" sldId="258"/>
+            <ac:picMk id="2" creationId="{1B68C1D3-9CF9-B505-1348-5056B9FCF823}"/>
+          </ac:picMkLst>
+        </pc:picChg>
+        <pc:picChg chg="mod">
+          <ac:chgData name="Stuart Fraser" userId="3f3d4742-f700-4c44-8ff3-de94e21c092c" providerId="ADAL" clId="{4782FBF3-262C-4F12-9567-4FCBC2EBDED3}" dt="2026-03-18T09:57:04.662" v="39"/>
+          <ac:picMkLst>
+            <pc:docMk/>
+            <pc:sldMk cId="2537370530" sldId="258"/>
+            <ac:picMk id="11" creationId="{DE1C3E70-5D98-8940-6C40-9CE058134B33}"/>
+          </ac:picMkLst>
+        </pc:picChg>
+      </pc:sldChg>
+      <pc:sldChg chg="modSp mod">
+        <pc:chgData name="Stuart Fraser" userId="3f3d4742-f700-4c44-8ff3-de94e21c092c" providerId="ADAL" clId="{4782FBF3-262C-4F12-9567-4FCBC2EBDED3}" dt="2026-03-18T09:54:49.101" v="6" actId="20577"/>
+        <pc:sldMkLst>
+          <pc:docMk/>
+          <pc:sldMk cId="2943542779" sldId="259"/>
+        </pc:sldMkLst>
+        <pc:spChg chg="mod">
+          <ac:chgData name="Stuart Fraser" userId="3f3d4742-f700-4c44-8ff3-de94e21c092c" providerId="ADAL" clId="{4782FBF3-262C-4F12-9567-4FCBC2EBDED3}" dt="2026-03-18T09:54:45.964" v="4" actId="20577"/>
+          <ac:spMkLst>
+            <pc:docMk/>
+            <pc:sldMk cId="2943542779" sldId="259"/>
+            <ac:spMk id="5" creationId="{C9D72538-6BC8-E579-8B15-1C366680BCF6}"/>
+          </ac:spMkLst>
+        </pc:spChg>
+        <pc:spChg chg="mod">
+          <ac:chgData name="Stuart Fraser" userId="3f3d4742-f700-4c44-8ff3-de94e21c092c" providerId="ADAL" clId="{4782FBF3-262C-4F12-9567-4FCBC2EBDED3}" dt="2026-03-18T09:54:49.101" v="6" actId="20577"/>
+          <ac:spMkLst>
+            <pc:docMk/>
+            <pc:sldMk cId="2943542779" sldId="259"/>
+            <ac:spMk id="6" creationId="{81C0BE87-290E-FD7A-75BA-2C3FBC197AA0}"/>
+          </ac:spMkLst>
+        </pc:spChg>
+      </pc:sldChg>
+      <pc:sldChg chg="modSp mod">
+        <pc:chgData name="Stuart Fraser" userId="3f3d4742-f700-4c44-8ff3-de94e21c092c" providerId="ADAL" clId="{4782FBF3-262C-4F12-9567-4FCBC2EBDED3}" dt="2026-03-18T09:54:32.782" v="3" actId="20577"/>
+        <pc:sldMkLst>
+          <pc:docMk/>
+          <pc:sldMk cId="916751020" sldId="260"/>
+        </pc:sldMkLst>
+        <pc:spChg chg="mod">
+          <ac:chgData name="Stuart Fraser" userId="3f3d4742-f700-4c44-8ff3-de94e21c092c" providerId="ADAL" clId="{4782FBF3-262C-4F12-9567-4FCBC2EBDED3}" dt="2026-03-18T09:54:30.733" v="1" actId="20577"/>
+          <ac:spMkLst>
+            <pc:docMk/>
+            <pc:sldMk cId="916751020" sldId="260"/>
+            <ac:spMk id="5" creationId="{7B76343E-0BBB-11F4-76DF-CCA00B00CA00}"/>
+          </ac:spMkLst>
+        </pc:spChg>
+        <pc:spChg chg="mod">
+          <ac:chgData name="Stuart Fraser" userId="3f3d4742-f700-4c44-8ff3-de94e21c092c" providerId="ADAL" clId="{4782FBF3-262C-4F12-9567-4FCBC2EBDED3}" dt="2026-03-18T09:54:32.782" v="3" actId="20577"/>
+          <ac:spMkLst>
+            <pc:docMk/>
+            <pc:sldMk cId="916751020" sldId="260"/>
+            <ac:spMk id="6" creationId="{BBBF3D4B-7838-42FB-ACF1-3A631F9CFB75}"/>
+          </ac:spMkLst>
+        </pc:spChg>
+      </pc:sldChg>
+    </pc:docChg>
+  </pc:docChgLst>
+</pc:chgInfo>
 </file>
 
 <file path=ppt/slideLayouts/slideLayout1.xml><?xml version="1.0" encoding="utf-8"?>
@@ -259,7 +491,7 @@
           <a:p>
             <a:fld id="{9CA97E6C-B71B-0746-8C67-4237547433A2}" type="datetimeFigureOut">
               <a:rPr lang="en-GB" smtClean="0"/>
-              <a:t>20/10/2025</a:t>
+              <a:t>18/03/2026</a:t>
             </a:fld>
             <a:endParaRPr lang="en-GB"/>
           </a:p>
@@ -457,7 +689,7 @@
           <a:p>
             <a:fld id="{9CA97E6C-B71B-0746-8C67-4237547433A2}" type="datetimeFigureOut">
               <a:rPr lang="en-GB" smtClean="0"/>
-              <a:t>20/10/2025</a:t>
+              <a:t>18/03/2026</a:t>
             </a:fld>
             <a:endParaRPr lang="en-GB"/>
           </a:p>
@@ -665,7 +897,7 @@
           <a:p>
             <a:fld id="{9CA97E6C-B71B-0746-8C67-4237547433A2}" type="datetimeFigureOut">
               <a:rPr lang="en-GB" smtClean="0"/>
-              <a:t>20/10/2025</a:t>
+              <a:t>18/03/2026</a:t>
             </a:fld>
             <a:endParaRPr lang="en-GB"/>
           </a:p>
@@ -863,7 +1095,7 @@
           <a:p>
             <a:fld id="{9CA97E6C-B71B-0746-8C67-4237547433A2}" type="datetimeFigureOut">
               <a:rPr lang="en-GB" smtClean="0"/>
-              <a:t>20/10/2025</a:t>
+              <a:t>18/03/2026</a:t>
             </a:fld>
             <a:endParaRPr lang="en-GB"/>
           </a:p>
@@ -1138,7 +1370,7 @@
           <a:p>
             <a:fld id="{9CA97E6C-B71B-0746-8C67-4237547433A2}" type="datetimeFigureOut">
               <a:rPr lang="en-GB" smtClean="0"/>
-              <a:t>20/10/2025</a:t>
+              <a:t>18/03/2026</a:t>
             </a:fld>
             <a:endParaRPr lang="en-GB"/>
           </a:p>
@@ -1403,7 +1635,7 @@
           <a:p>
             <a:fld id="{9CA97E6C-B71B-0746-8C67-4237547433A2}" type="datetimeFigureOut">
               <a:rPr lang="en-GB" smtClean="0"/>
-              <a:t>20/10/2025</a:t>
+              <a:t>18/03/2026</a:t>
             </a:fld>
             <a:endParaRPr lang="en-GB"/>
           </a:p>
@@ -1815,7 +2047,7 @@
           <a:p>
             <a:fld id="{9CA97E6C-B71B-0746-8C67-4237547433A2}" type="datetimeFigureOut">
               <a:rPr lang="en-GB" smtClean="0"/>
-              <a:t>20/10/2025</a:t>
+              <a:t>18/03/2026</a:t>
             </a:fld>
             <a:endParaRPr lang="en-GB"/>
           </a:p>
@@ -1956,7 +2188,7 @@
           <a:p>
             <a:fld id="{9CA97E6C-B71B-0746-8C67-4237547433A2}" type="datetimeFigureOut">
               <a:rPr lang="en-GB" smtClean="0"/>
-              <a:t>20/10/2025</a:t>
+              <a:t>18/03/2026</a:t>
             </a:fld>
             <a:endParaRPr lang="en-GB"/>
           </a:p>
@@ -2069,7 +2301,7 @@
           <a:p>
             <a:fld id="{9CA97E6C-B71B-0746-8C67-4237547433A2}" type="datetimeFigureOut">
               <a:rPr lang="en-GB" smtClean="0"/>
-              <a:t>20/10/2025</a:t>
+              <a:t>18/03/2026</a:t>
             </a:fld>
             <a:endParaRPr lang="en-GB"/>
           </a:p>
@@ -2380,7 +2612,7 @@
           <a:p>
             <a:fld id="{9CA97E6C-B71B-0746-8C67-4237547433A2}" type="datetimeFigureOut">
               <a:rPr lang="en-GB" smtClean="0"/>
-              <a:t>20/10/2025</a:t>
+              <a:t>18/03/2026</a:t>
             </a:fld>
             <a:endParaRPr lang="en-GB"/>
           </a:p>
@@ -2668,7 +2900,7 @@
           <a:p>
             <a:fld id="{9CA97E6C-B71B-0746-8C67-4237547433A2}" type="datetimeFigureOut">
               <a:rPr lang="en-GB" smtClean="0"/>
-              <a:t>20/10/2025</a:t>
+              <a:t>18/03/2026</a:t>
             </a:fld>
             <a:endParaRPr lang="en-GB"/>
           </a:p>
@@ -2909,7 +3141,7 @@
           <a:p>
             <a:fld id="{9CA97E6C-B71B-0746-8C67-4237547433A2}" type="datetimeFigureOut">
               <a:rPr lang="en-GB" smtClean="0"/>
-              <a:t>20/10/2025</a:t>
+              <a:t>18/03/2026</a:t>
             </a:fld>
             <a:endParaRPr lang="en-GB"/>
           </a:p>
@@ -4043,10 +4275,10 @@
       </p:grpSpPr>
       <p:grpSp>
         <p:nvGrpSpPr>
-          <p:cNvPr id="24" name="Group 23">
-            <a:extLst>
-              <a:ext uri="{FF2B5EF4-FFF2-40B4-BE49-F238E27FC236}">
-                <a16:creationId xmlns:a16="http://schemas.microsoft.com/office/drawing/2014/main" id="{4FB0F79C-3646-B32F-9F26-35175F338988}"/>
+          <p:cNvPr id="9" name="Group 8">
+            <a:extLst>
+              <a:ext uri="{FF2B5EF4-FFF2-40B4-BE49-F238E27FC236}">
+                <a16:creationId xmlns:a16="http://schemas.microsoft.com/office/drawing/2014/main" id="{F2224106-0FA1-7AAB-B155-D686EB02A6E1}"/>
               </a:ext>
             </a:extLst>
           </p:cNvPr>
@@ -4056,9 +4288,9 @@
         <p:grpSpPr>
           <a:xfrm>
             <a:off x="3197184" y="2393224"/>
-            <a:ext cx="5154525" cy="2687252"/>
+            <a:ext cx="6311832" cy="2502586"/>
             <a:chOff x="3197184" y="2393224"/>
-            <a:chExt cx="5154525" cy="2687252"/>
+            <a:chExt cx="6311832" cy="2502586"/>
           </a:xfrm>
         </p:grpSpPr>
         <p:pic>
@@ -4104,7 +4336,7 @@
           </p:nvSpPr>
           <p:spPr>
             <a:xfrm>
-              <a:off x="6709891" y="2433779"/>
+              <a:off x="7286800" y="2429447"/>
               <a:ext cx="971741" cy="369332"/>
             </a:xfrm>
             <a:prstGeom prst="rect">
@@ -4141,7 +4373,7 @@
           <p:spPr>
             <a:xfrm>
               <a:off x="6028220" y="4064813"/>
-              <a:ext cx="1158076" cy="1015663"/>
+              <a:ext cx="1158076" cy="830997"/>
             </a:xfrm>
             <a:prstGeom prst="rect">
               <a:avLst/>
@@ -4157,7 +4389,7 @@
               <a:pPr algn="ctr"/>
               <a:r>
                 <a:rPr lang="en-GB" sz="1200" dirty="0"/>
-                <a:t>Review funding coverage for each country-risk</a:t>
+                <a:t>Review funding coverage: across pool</a:t>
               </a:r>
             </a:p>
           </p:txBody>
@@ -4177,7 +4409,7 @@
           <p:spPr>
             <a:xfrm>
               <a:off x="7193633" y="4059220"/>
-              <a:ext cx="1158076" cy="646331"/>
+              <a:ext cx="1158076" cy="830997"/>
             </a:xfrm>
             <a:prstGeom prst="rect">
               <a:avLst/>
@@ -4193,7 +4425,7 @@
               <a:pPr algn="ctr"/>
               <a:r>
                 <a:rPr lang="en-GB" sz="1200" dirty="0"/>
-                <a:t>Check coverage vs. country needs</a:t>
+                <a:t>Review funding coverage: each country</a:t>
               </a:r>
             </a:p>
           </p:txBody>
@@ -4308,6 +4540,99 @@
               <a:r>
                 <a:rPr lang="en-GB" sz="1400" dirty="0"/>
                 <a:t>Step 7</a:t>
+              </a:r>
+            </a:p>
+          </p:txBody>
+        </p:sp>
+        <p:sp>
+          <p:nvSpPr>
+            <p:cNvPr id="3" name="TextBox 2">
+              <a:extLst>
+                <a:ext uri="{FF2B5EF4-FFF2-40B4-BE49-F238E27FC236}">
+                  <a16:creationId xmlns:a16="http://schemas.microsoft.com/office/drawing/2014/main" id="{03D0E77F-3659-73AE-F720-BB04B4058136}"/>
+                </a:ext>
+              </a:extLst>
+            </p:cNvPr>
+            <p:cNvSpPr txBox="1"/>
+            <p:nvPr/>
+          </p:nvSpPr>
+          <p:spPr>
+            <a:xfrm>
+              <a:off x="8350940" y="4059220"/>
+              <a:ext cx="1158076" cy="646331"/>
+            </a:xfrm>
+            <a:prstGeom prst="rect">
+              <a:avLst/>
+            </a:prstGeom>
+            <a:noFill/>
+          </p:spPr>
+          <p:txBody>
+            <a:bodyPr wrap="square" rtlCol="0">
+              <a:spAutoFit/>
+            </a:bodyPr>
+            <a:lstStyle/>
+            <a:p>
+              <a:pPr algn="ctr"/>
+              <a:r>
+                <a:rPr lang="en-GB" sz="1200" dirty="0"/>
+                <a:t>Check coverage vs. country needs</a:t>
+              </a:r>
+            </a:p>
+          </p:txBody>
+        </p:sp>
+        <p:sp>
+          <p:nvSpPr>
+            <p:cNvPr id="7" name="Oval 6">
+              <a:extLst>
+                <a:ext uri="{FF2B5EF4-FFF2-40B4-BE49-F238E27FC236}">
+                  <a16:creationId xmlns:a16="http://schemas.microsoft.com/office/drawing/2014/main" id="{51AA527A-B7A0-8489-F95C-ADF4C6719403}"/>
+                </a:ext>
+              </a:extLst>
+            </p:cNvPr>
+            <p:cNvSpPr/>
+            <p:nvPr/>
+          </p:nvSpPr>
+          <p:spPr>
+            <a:xfrm>
+              <a:off x="8444964" y="2943446"/>
+              <a:ext cx="971107" cy="971107"/>
+            </a:xfrm>
+            <a:prstGeom prst="ellipse">
+              <a:avLst/>
+            </a:prstGeom>
+            <a:solidFill>
+              <a:srgbClr val="AE7351"/>
+            </a:solidFill>
+            <a:ln>
+              <a:solidFill>
+                <a:srgbClr val="AE7351"/>
+              </a:solidFill>
+            </a:ln>
+          </p:spPr>
+          <p:style>
+            <a:lnRef idx="2">
+              <a:schemeClr val="accent1">
+                <a:shade val="15000"/>
+              </a:schemeClr>
+            </a:lnRef>
+            <a:fillRef idx="1">
+              <a:schemeClr val="accent1"/>
+            </a:fillRef>
+            <a:effectRef idx="0">
+              <a:schemeClr val="accent1"/>
+            </a:effectRef>
+            <a:fontRef idx="minor">
+              <a:schemeClr val="lt1"/>
+            </a:fontRef>
+          </p:style>
+          <p:txBody>
+            <a:bodyPr rtlCol="0" anchor="ctr"/>
+            <a:lstStyle/>
+            <a:p>
+              <a:pPr algn="ctr"/>
+              <a:r>
+                <a:rPr lang="en-GB" sz="1400" dirty="0"/>
+                <a:t>Step 8</a:t>
               </a:r>
             </a:p>
           </p:txBody>
@@ -4558,7 +4883,7 @@
               <a:pPr algn="ctr"/>
               <a:r>
                 <a:rPr lang="en-GB" sz="1400" dirty="0"/>
-                <a:t>Step 8</a:t>
+                <a:t>Step 9</a:t>
               </a:r>
             </a:p>
           </p:txBody>
@@ -4615,7 +4940,7 @@
               <a:pPr algn="ctr"/>
               <a:r>
                 <a:rPr lang="en-GB" sz="1400" dirty="0"/>
-                <a:t>Step 9</a:t>
+                <a:t>Step 10</a:t>
               </a:r>
             </a:p>
           </p:txBody>
@@ -4866,7 +5191,7 @@
               <a:pPr algn="ctr"/>
               <a:r>
                 <a:rPr lang="en-GB" sz="1400" dirty="0"/>
-                <a:t>Step 10</a:t>
+                <a:t>Step 11</a:t>
               </a:r>
             </a:p>
           </p:txBody>
@@ -4923,7 +5248,7 @@
               <a:pPr algn="ctr"/>
               <a:r>
                 <a:rPr lang="en-GB" sz="1400" dirty="0"/>
-                <a:t>Step 11</a:t>
+                <a:t>Step 12</a:t>
               </a:r>
             </a:p>
           </p:txBody>

</xml_diff>